<commit_message>
Fix KPI label collision on the deck's bound slide
Rendering the generated deck caught the pair names overflowing their
2.8in KPI boxes and colliding with neighbours. Added short display names
(GUINEA/PETAL rather than GOLDGUINEA/GOLDPETAL) and explicit font sizes.
</commit_message>
<xml_diff>
--- a/docs/arb-bound-deck.pptx
+++ b/docs/arb-bound-deck.pptx
@@ -11689,12 +11689,12 @@
           </a:fontRef>
         </p:style>
         <p:txBody>
-          <a:bodyPr rtlCol="0" anchor="ctr" wrap="square" lIns="164592" tIns="109728"/>
+          <a:bodyPr rtlCol="0" anchor="ctr" wrap="square" lIns="128016" tIns="109728"/>
           <a:lstStyle/>
           <a:p>
             <a:pPr algn="ctr"/>
             <a:r>
-              <a:rPr sz="3000" b="1">
+              <a:rPr sz="2600" b="1">
                 <a:solidFill>
                   <a:srgbClr val="A03030"/>
                 </a:solidFill>
@@ -11705,13 +11705,13 @@
           </a:p>
           <a:p>
             <a:r>
-              <a:rPr sz="1100">
+              <a:rPr sz="1200">
                 <a:solidFill>
                   <a:srgbClr val="6B6862"/>
                 </a:solidFill>
                 <a:latin typeface="Inter"/>
               </a:rPr>
-              <a:t>GOLDGUINEA/GOLDM  (bps)</a:t>
+              <a:t>GUINEA / M</a:t>
             </a:r>
           </a:p>
         </p:txBody>
@@ -11755,12 +11755,12 @@
           </a:fontRef>
         </p:style>
         <p:txBody>
-          <a:bodyPr rtlCol="0" anchor="ctr" wrap="square" lIns="164592" tIns="109728"/>
+          <a:bodyPr rtlCol="0" anchor="ctr" wrap="square" lIns="128016" tIns="109728"/>
           <a:lstStyle/>
           <a:p>
             <a:pPr algn="ctr"/>
             <a:r>
-              <a:rPr sz="3000" b="1">
+              <a:rPr sz="2600" b="1">
                 <a:solidFill>
                   <a:srgbClr val="A67C00"/>
                 </a:solidFill>
@@ -11771,13 +11771,13 @@
           </a:p>
           <a:p>
             <a:r>
-              <a:rPr sz="1100">
+              <a:rPr sz="1200">
                 <a:solidFill>
                   <a:srgbClr val="6B6862"/>
                 </a:solidFill>
                 <a:latin typeface="Inter"/>
               </a:rPr>
-              <a:t>GOLDGUINEA/GOLDPETAL  (bps)</a:t>
+              <a:t>GUINEA / PETAL</a:t>
             </a:r>
           </a:p>
         </p:txBody>
@@ -11821,12 +11821,12 @@
           </a:fontRef>
         </p:style>
         <p:txBody>
-          <a:bodyPr rtlCol="0" anchor="ctr" wrap="square" lIns="164592" tIns="109728"/>
+          <a:bodyPr rtlCol="0" anchor="ctr" wrap="square" lIns="128016" tIns="109728"/>
           <a:lstStyle/>
           <a:p>
             <a:pPr algn="ctr"/>
             <a:r>
-              <a:rPr sz="3000" b="1">
+              <a:rPr sz="2600" b="1">
                 <a:solidFill>
                   <a:srgbClr val="A67C00"/>
                 </a:solidFill>
@@ -11837,13 +11837,13 @@
           </a:p>
           <a:p>
             <a:r>
-              <a:rPr sz="1100">
+              <a:rPr sz="1200">
                 <a:solidFill>
                   <a:srgbClr val="6B6862"/>
                 </a:solidFill>
                 <a:latin typeface="Inter"/>
               </a:rPr>
-              <a:t>GOLDGUINEA/GOLDTEN  (bps)</a:t>
+              <a:t>GUINEA / TEN</a:t>
             </a:r>
           </a:p>
         </p:txBody>
@@ -11887,12 +11887,12 @@
           </a:fontRef>
         </p:style>
         <p:txBody>
-          <a:bodyPr rtlCol="0" anchor="ctr" wrap="square" lIns="164592" tIns="109728"/>
+          <a:bodyPr rtlCol="0" anchor="ctr" wrap="square" lIns="128016" tIns="109728"/>
           <a:lstStyle/>
           <a:p>
             <a:pPr algn="ctr"/>
             <a:r>
-              <a:rPr sz="3000" b="1">
+              <a:rPr sz="2600" b="1">
                 <a:solidFill>
                   <a:srgbClr val="A03030"/>
                 </a:solidFill>
@@ -11903,13 +11903,13 @@
           </a:p>
           <a:p>
             <a:r>
-              <a:rPr sz="1100">
+              <a:rPr sz="1200">
                 <a:solidFill>
                   <a:srgbClr val="6B6862"/>
                 </a:solidFill>
                 <a:latin typeface="Inter"/>
               </a:rPr>
-              <a:t>GOLDM/GOLDPETAL  (bps)</a:t>
+              <a:t>M / PETAL</a:t>
             </a:r>
           </a:p>
         </p:txBody>
@@ -11953,12 +11953,12 @@
           </a:fontRef>
         </p:style>
         <p:txBody>
-          <a:bodyPr rtlCol="0" anchor="ctr" wrap="square" lIns="164592" tIns="109728"/>
+          <a:bodyPr rtlCol="0" anchor="ctr" wrap="square" lIns="128016" tIns="109728"/>
           <a:lstStyle/>
           <a:p>
             <a:pPr algn="ctr"/>
             <a:r>
-              <a:rPr sz="3000" b="1">
+              <a:rPr sz="2600" b="1">
                 <a:solidFill>
                   <a:srgbClr val="A03030"/>
                 </a:solidFill>
@@ -11969,13 +11969,13 @@
           </a:p>
           <a:p>
             <a:r>
-              <a:rPr sz="1100">
+              <a:rPr sz="1200">
                 <a:solidFill>
                   <a:srgbClr val="6B6862"/>
                 </a:solidFill>
                 <a:latin typeface="Inter"/>
               </a:rPr>
-              <a:t>GOLDM/GOLDTEN  (bps)</a:t>
+              <a:t>M / TEN</a:t>
             </a:r>
           </a:p>
         </p:txBody>
@@ -12019,12 +12019,12 @@
           </a:fontRef>
         </p:style>
         <p:txBody>
-          <a:bodyPr rtlCol="0" anchor="ctr" wrap="square" lIns="164592" tIns="109728"/>
+          <a:bodyPr rtlCol="0" anchor="ctr" wrap="square" lIns="128016" tIns="109728"/>
           <a:lstStyle/>
           <a:p>
             <a:pPr algn="ctr"/>
             <a:r>
-              <a:rPr sz="3000" b="1">
+              <a:rPr sz="2600" b="1">
                 <a:solidFill>
                   <a:srgbClr val="A67C00"/>
                 </a:solidFill>
@@ -12035,13 +12035,13 @@
           </a:p>
           <a:p>
             <a:r>
-              <a:rPr sz="1100">
+              <a:rPr sz="1200">
                 <a:solidFill>
                   <a:srgbClr val="6B6862"/>
                 </a:solidFill>
                 <a:latin typeface="Inter"/>
               </a:rPr>
-              <a:t>GOLDPETAL/GOLDTEN  (bps)</a:t>
+              <a:t>PETAL / TEN</a:t>
             </a:r>
           </a:p>
         </p:txBody>
@@ -12898,7 +12898,7 @@
           </a:fontRef>
         </p:style>
         <p:txBody>
-          <a:bodyPr rtlCol="0" anchor="ctr" wrap="square" lIns="164592" tIns="109728"/>
+          <a:bodyPr rtlCol="0" anchor="ctr" wrap="square" lIns="128016" tIns="109728"/>
           <a:lstStyle/>
           <a:p>
             <a:pPr algn="ctr"/>
@@ -12914,7 +12914,7 @@
           </a:p>
           <a:p>
             <a:r>
-              <a:rPr sz="1100">
+              <a:rPr sz="1200">
                 <a:solidFill>
                   <a:srgbClr val="6B6862"/>
                 </a:solidFill>
@@ -12964,7 +12964,7 @@
           </a:fontRef>
         </p:style>
         <p:txBody>
-          <a:bodyPr rtlCol="0" anchor="ctr" wrap="square" lIns="164592" tIns="109728"/>
+          <a:bodyPr rtlCol="0" anchor="ctr" wrap="square" lIns="128016" tIns="109728"/>
           <a:lstStyle/>
           <a:p>
             <a:pPr algn="ctr"/>
@@ -12980,7 +12980,7 @@
           </a:p>
           <a:p>
             <a:r>
-              <a:rPr sz="1100">
+              <a:rPr sz="1200">
                 <a:solidFill>
                   <a:srgbClr val="6B6862"/>
                 </a:solidFill>
@@ -13030,7 +13030,7 @@
           </a:fontRef>
         </p:style>
         <p:txBody>
-          <a:bodyPr rtlCol="0" anchor="ctr" wrap="square" lIns="164592" tIns="109728"/>
+          <a:bodyPr rtlCol="0" anchor="ctr" wrap="square" lIns="128016" tIns="109728"/>
           <a:lstStyle/>
           <a:p>
             <a:pPr algn="ctr"/>
@@ -13046,13 +13046,13 @@
           </a:p>
           <a:p>
             <a:r>
-              <a:rPr sz="1100">
+              <a:rPr sz="1200">
                 <a:solidFill>
                   <a:srgbClr val="6B6862"/>
                 </a:solidFill>
                 <a:latin typeface="Inter"/>
               </a:rPr>
-              <a:t>pairs with a stable structural level</a:t>
+              <a:t>pairs with a stable level</a:t>
             </a:r>
           </a:p>
         </p:txBody>
@@ -13096,7 +13096,7 @@
           </a:fontRef>
         </p:style>
         <p:txBody>
-          <a:bodyPr rtlCol="0" anchor="ctr" wrap="square" lIns="164592" tIns="109728"/>
+          <a:bodyPr rtlCol="0" anchor="ctr" wrap="square" lIns="128016" tIns="109728"/>
           <a:lstStyle/>
           <a:p>
             <a:pPr algn="ctr"/>
@@ -13112,13 +13112,13 @@
           </a:p>
           <a:p>
             <a:r>
-              <a:rPr sz="1100">
+              <a:rPr sz="1200">
                 <a:solidFill>
                   <a:srgbClr val="6B6862"/>
                 </a:solidFill>
                 <a:latin typeface="Inter"/>
               </a:rPr>
-              <a:t>persistent edges that survive costs</a:t>
+              <a:t>persistent edges survive costs</a:t>
             </a:r>
           </a:p>
         </p:txBody>

</xml_diff>